<commit_message>
fix: slide 16 architecture diagram — compress y-layout to fit within 7.5in slide height
</commit_message>
<xml_diff>
--- a/docs/ppt_updated.pptx
+++ b/docs/ppt_updated.pptx
@@ -5876,7 +5876,7 @@
         <p:spPr>
           <a:xfrm>
             <a:off x="0" y="0"/>
-            <a:ext cx="12188952" cy="594360"/>
+            <a:ext cx="12188952" cy="457200"/>
           </a:xfrm>
           <a:prstGeom prst="rect">
             <a:avLst/>
@@ -5918,8 +5918,8 @@
         </p:nvSpPr>
         <p:spPr>
           <a:xfrm>
-            <a:off x="182880" y="45720"/>
-            <a:ext cx="11795760" cy="502920"/>
+            <a:off x="182880" y="36576"/>
+            <a:ext cx="11795760" cy="402336"/>
           </a:xfrm>
           <a:prstGeom prst="rect">
             <a:avLst/>
@@ -5934,7 +5934,7 @@
           <a:p>
             <a:pPr algn="ctr"/>
             <a:r>
-              <a:rPr sz="2400" b="1" i="0">
+              <a:rPr sz="2200" b="1" i="0">
                 <a:solidFill>
                   <a:srgbClr val="0D1B2A"/>
                 </a:solidFill>
@@ -5952,8 +5952,8 @@
         </p:nvSpPr>
         <p:spPr>
           <a:xfrm>
-            <a:off x="160020" y="1088136"/>
-            <a:ext cx="1691640" cy="658368"/>
+            <a:off x="173736" y="676656"/>
+            <a:ext cx="1664208" cy="566928"/>
           </a:xfrm>
           <a:prstGeom prst="rect">
             <a:avLst/>
@@ -5997,8 +5997,8 @@
         </p:nvSpPr>
         <p:spPr>
           <a:xfrm>
-            <a:off x="160020" y="1088136"/>
-            <a:ext cx="1691640" cy="45720"/>
+            <a:off x="173736" y="676656"/>
+            <a:ext cx="1664208" cy="45720"/>
           </a:xfrm>
           <a:prstGeom prst="rect">
             <a:avLst/>
@@ -6040,8 +6040,8 @@
         </p:nvSpPr>
         <p:spPr>
           <a:xfrm>
-            <a:off x="160020" y="1124712"/>
-            <a:ext cx="1691640" cy="292608"/>
+            <a:off x="173736" y="722376"/>
+            <a:ext cx="1664208" cy="256032"/>
           </a:xfrm>
           <a:prstGeom prst="rect">
             <a:avLst/>
@@ -6056,7 +6056,7 @@
           <a:p>
             <a:pPr algn="ctr"/>
             <a:r>
-              <a:rPr sz="1050" b="1" i="0">
+              <a:rPr sz="1000" b="1" i="0">
                 <a:solidFill>
                   <a:srgbClr val="00B4D8"/>
                 </a:solidFill>
@@ -6074,8 +6074,8 @@
         </p:nvSpPr>
         <p:spPr>
           <a:xfrm>
-            <a:off x="160020" y="1408176"/>
-            <a:ext cx="1691640" cy="274320"/>
+            <a:off x="173736" y="969264"/>
+            <a:ext cx="1664208" cy="237744"/>
           </a:xfrm>
           <a:prstGeom prst="rect">
             <a:avLst/>
@@ -6090,7 +6090,7 @@
           <a:p>
             <a:pPr algn="ctr"/>
             <a:r>
-              <a:rPr sz="900" b="0" i="0">
+              <a:rPr sz="850" b="0" i="0">
                 <a:solidFill>
                   <a:srgbClr val="CCCCCC"/>
                 </a:solidFill>
@@ -6108,8 +6108,8 @@
         </p:nvSpPr>
         <p:spPr>
           <a:xfrm>
-            <a:off x="1988819" y="1088136"/>
-            <a:ext cx="1691640" cy="658368"/>
+            <a:off x="2002536" y="676656"/>
+            <a:ext cx="1664208" cy="566928"/>
           </a:xfrm>
           <a:prstGeom prst="rect">
             <a:avLst/>
@@ -6153,8 +6153,8 @@
         </p:nvSpPr>
         <p:spPr>
           <a:xfrm>
-            <a:off x="1988819" y="1088136"/>
-            <a:ext cx="1691640" cy="45720"/>
+            <a:off x="2002536" y="676656"/>
+            <a:ext cx="1664208" cy="45720"/>
           </a:xfrm>
           <a:prstGeom prst="rect">
             <a:avLst/>
@@ -6196,8 +6196,8 @@
         </p:nvSpPr>
         <p:spPr>
           <a:xfrm>
-            <a:off x="1988819" y="1124712"/>
-            <a:ext cx="1691640" cy="292608"/>
+            <a:off x="2002536" y="722376"/>
+            <a:ext cx="1664208" cy="256032"/>
           </a:xfrm>
           <a:prstGeom prst="rect">
             <a:avLst/>
@@ -6212,7 +6212,7 @@
           <a:p>
             <a:pPr algn="ctr"/>
             <a:r>
-              <a:rPr sz="1050" b="1" i="0">
+              <a:rPr sz="1000" b="1" i="0">
                 <a:solidFill>
                   <a:srgbClr val="0096C7"/>
                 </a:solidFill>
@@ -6230,8 +6230,8 @@
         </p:nvSpPr>
         <p:spPr>
           <a:xfrm>
-            <a:off x="1988819" y="1408176"/>
-            <a:ext cx="1691640" cy="274320"/>
+            <a:off x="2002536" y="969264"/>
+            <a:ext cx="1664208" cy="237744"/>
           </a:xfrm>
           <a:prstGeom prst="rect">
             <a:avLst/>
@@ -6246,7 +6246,7 @@
           <a:p>
             <a:pPr algn="ctr"/>
             <a:r>
-              <a:rPr sz="900" b="0" i="0">
+              <a:rPr sz="850" b="0" i="0">
                 <a:solidFill>
                   <a:srgbClr val="CCCCCC"/>
                 </a:solidFill>
@@ -6264,8 +6264,8 @@
         </p:nvSpPr>
         <p:spPr>
           <a:xfrm>
-            <a:off x="3817620" y="1088136"/>
-            <a:ext cx="1691640" cy="658368"/>
+            <a:off x="3831335" y="676656"/>
+            <a:ext cx="1664208" cy="566928"/>
           </a:xfrm>
           <a:prstGeom prst="rect">
             <a:avLst/>
@@ -6309,8 +6309,8 @@
         </p:nvSpPr>
         <p:spPr>
           <a:xfrm>
-            <a:off x="3817620" y="1088136"/>
-            <a:ext cx="1691640" cy="45720"/>
+            <a:off x="3831335" y="676656"/>
+            <a:ext cx="1664208" cy="45720"/>
           </a:xfrm>
           <a:prstGeom prst="rect">
             <a:avLst/>
@@ -6352,8 +6352,8 @@
         </p:nvSpPr>
         <p:spPr>
           <a:xfrm>
-            <a:off x="3817620" y="1124712"/>
-            <a:ext cx="1691640" cy="292608"/>
+            <a:off x="3831335" y="722376"/>
+            <a:ext cx="1664208" cy="256032"/>
           </a:xfrm>
           <a:prstGeom prst="rect">
             <a:avLst/>
@@ -6368,7 +6368,7 @@
           <a:p>
             <a:pPr algn="ctr"/>
             <a:r>
-              <a:rPr sz="1050" b="1" i="0">
+              <a:rPr sz="1000" b="1" i="0">
                 <a:solidFill>
                   <a:srgbClr val="0077B6"/>
                 </a:solidFill>
@@ -6386,8 +6386,8 @@
         </p:nvSpPr>
         <p:spPr>
           <a:xfrm>
-            <a:off x="3817620" y="1408176"/>
-            <a:ext cx="1691640" cy="274320"/>
+            <a:off x="3831335" y="969264"/>
+            <a:ext cx="1664208" cy="237744"/>
           </a:xfrm>
           <a:prstGeom prst="rect">
             <a:avLst/>
@@ -6402,7 +6402,7 @@
           <a:p>
             <a:pPr algn="ctr"/>
             <a:r>
-              <a:rPr sz="900" b="0" i="0">
+              <a:rPr sz="850" b="0" i="0">
                 <a:solidFill>
                   <a:srgbClr val="CCCCCC"/>
                 </a:solidFill>
@@ -6420,8 +6420,8 @@
         </p:nvSpPr>
         <p:spPr>
           <a:xfrm>
-            <a:off x="5646420" y="1088136"/>
-            <a:ext cx="1691640" cy="658368"/>
+            <a:off x="5660136" y="676656"/>
+            <a:ext cx="1664208" cy="566928"/>
           </a:xfrm>
           <a:prstGeom prst="rect">
             <a:avLst/>
@@ -6465,8 +6465,8 @@
         </p:nvSpPr>
         <p:spPr>
           <a:xfrm>
-            <a:off x="5646420" y="1088136"/>
-            <a:ext cx="1691640" cy="45720"/>
+            <a:off x="5660136" y="676656"/>
+            <a:ext cx="1664208" cy="45720"/>
           </a:xfrm>
           <a:prstGeom prst="rect">
             <a:avLst/>
@@ -6508,8 +6508,8 @@
         </p:nvSpPr>
         <p:spPr>
           <a:xfrm>
-            <a:off x="5646420" y="1124712"/>
-            <a:ext cx="1691640" cy="292608"/>
+            <a:off x="5660136" y="722376"/>
+            <a:ext cx="1664208" cy="256032"/>
           </a:xfrm>
           <a:prstGeom prst="rect">
             <a:avLst/>
@@ -6524,7 +6524,7 @@
           <a:p>
             <a:pPr algn="ctr"/>
             <a:r>
-              <a:rPr sz="1050" b="1" i="0">
+              <a:rPr sz="1000" b="1" i="0">
                 <a:solidFill>
                   <a:srgbClr val="023E8A"/>
                 </a:solidFill>
@@ -6542,8 +6542,8 @@
         </p:nvSpPr>
         <p:spPr>
           <a:xfrm>
-            <a:off x="5646420" y="1408176"/>
-            <a:ext cx="1691640" cy="274320"/>
+            <a:off x="5660136" y="969264"/>
+            <a:ext cx="1664208" cy="237744"/>
           </a:xfrm>
           <a:prstGeom prst="rect">
             <a:avLst/>
@@ -6558,7 +6558,7 @@
           <a:p>
             <a:pPr algn="ctr"/>
             <a:r>
-              <a:rPr sz="900" b="0" i="0">
+              <a:rPr sz="850" b="0" i="0">
                 <a:solidFill>
                   <a:srgbClr val="CCCCCC"/>
                 </a:solidFill>
@@ -6576,8 +6576,8 @@
         </p:nvSpPr>
         <p:spPr>
           <a:xfrm>
-            <a:off x="7658100" y="1088136"/>
-            <a:ext cx="1691640" cy="658368"/>
+            <a:off x="7671816" y="676656"/>
+            <a:ext cx="1664208" cy="566928"/>
           </a:xfrm>
           <a:prstGeom prst="rect">
             <a:avLst/>
@@ -6621,8 +6621,8 @@
         </p:nvSpPr>
         <p:spPr>
           <a:xfrm>
-            <a:off x="7658100" y="1088136"/>
-            <a:ext cx="1691640" cy="45720"/>
+            <a:off x="7671816" y="676656"/>
+            <a:ext cx="1664208" cy="45720"/>
           </a:xfrm>
           <a:prstGeom prst="rect">
             <a:avLst/>
@@ -6664,8 +6664,8 @@
         </p:nvSpPr>
         <p:spPr>
           <a:xfrm>
-            <a:off x="7658100" y="1124712"/>
-            <a:ext cx="1691640" cy="292608"/>
+            <a:off x="7671816" y="722376"/>
+            <a:ext cx="1664208" cy="256032"/>
           </a:xfrm>
           <a:prstGeom prst="rect">
             <a:avLst/>
@@ -6680,7 +6680,7 @@
           <a:p>
             <a:pPr algn="ctr"/>
             <a:r>
-              <a:rPr sz="1050" b="1" i="0">
+              <a:rPr sz="1000" b="1" i="0">
                 <a:solidFill>
                   <a:srgbClr val="03045E"/>
                 </a:solidFill>
@@ -6698,8 +6698,8 @@
         </p:nvSpPr>
         <p:spPr>
           <a:xfrm>
-            <a:off x="7658100" y="1408176"/>
-            <a:ext cx="1691640" cy="274320"/>
+            <a:off x="7671816" y="969264"/>
+            <a:ext cx="1664208" cy="237744"/>
           </a:xfrm>
           <a:prstGeom prst="rect">
             <a:avLst/>
@@ -6714,7 +6714,7 @@
           <a:p>
             <a:pPr algn="ctr"/>
             <a:r>
-              <a:rPr sz="900" b="0" i="0">
+              <a:rPr sz="850" b="0" i="0">
                 <a:solidFill>
                   <a:srgbClr val="CCCCCC"/>
                 </a:solidFill>
@@ -6732,8 +6732,8 @@
         </p:nvSpPr>
         <p:spPr>
           <a:xfrm>
-            <a:off x="3817620" y="2688336"/>
-            <a:ext cx="1691640" cy="658368"/>
+            <a:off x="3831335" y="1591055"/>
+            <a:ext cx="1664208" cy="566928"/>
           </a:xfrm>
           <a:prstGeom prst="rect">
             <a:avLst/>
@@ -6777,8 +6777,8 @@
         </p:nvSpPr>
         <p:spPr>
           <a:xfrm>
-            <a:off x="3817620" y="2688336"/>
-            <a:ext cx="1691640" cy="45720"/>
+            <a:off x="3831335" y="1591055"/>
+            <a:ext cx="1664208" cy="45720"/>
           </a:xfrm>
           <a:prstGeom prst="rect">
             <a:avLst/>
@@ -6820,8 +6820,8 @@
         </p:nvSpPr>
         <p:spPr>
           <a:xfrm>
-            <a:off x="3817620" y="2724912"/>
-            <a:ext cx="1691640" cy="292608"/>
+            <a:off x="3831335" y="1636775"/>
+            <a:ext cx="1664208" cy="256032"/>
           </a:xfrm>
           <a:prstGeom prst="rect">
             <a:avLst/>
@@ -6836,7 +6836,7 @@
           <a:p>
             <a:pPr algn="ctr"/>
             <a:r>
-              <a:rPr sz="1050" b="1" i="0">
+              <a:rPr sz="1000" b="1" i="0">
                 <a:solidFill>
                   <a:srgbClr val="1B4332"/>
                 </a:solidFill>
@@ -6854,8 +6854,8 @@
         </p:nvSpPr>
         <p:spPr>
           <a:xfrm>
-            <a:off x="3817620" y="3008376"/>
-            <a:ext cx="1691640" cy="274320"/>
+            <a:off x="3831335" y="1883663"/>
+            <a:ext cx="1664208" cy="237744"/>
           </a:xfrm>
           <a:prstGeom prst="rect">
             <a:avLst/>
@@ -6870,7 +6870,7 @@
           <a:p>
             <a:pPr algn="ctr"/>
             <a:r>
-              <a:rPr sz="900" b="0" i="0">
+              <a:rPr sz="850" b="0" i="0">
                 <a:solidFill>
                   <a:srgbClr val="CCCCCC"/>
                 </a:solidFill>
@@ -6888,8 +6888,8 @@
         </p:nvSpPr>
         <p:spPr>
           <a:xfrm>
-            <a:off x="982980" y="4151376"/>
-            <a:ext cx="1691640" cy="658368"/>
+            <a:off x="996695" y="2505456"/>
+            <a:ext cx="1664208" cy="566928"/>
           </a:xfrm>
           <a:prstGeom prst="rect">
             <a:avLst/>
@@ -6933,8 +6933,8 @@
         </p:nvSpPr>
         <p:spPr>
           <a:xfrm>
-            <a:off x="982980" y="4151376"/>
-            <a:ext cx="1691640" cy="45720"/>
+            <a:off x="996695" y="2505456"/>
+            <a:ext cx="1664208" cy="45720"/>
           </a:xfrm>
           <a:prstGeom prst="rect">
             <a:avLst/>
@@ -6976,8 +6976,8 @@
         </p:nvSpPr>
         <p:spPr>
           <a:xfrm>
-            <a:off x="982980" y="4187952"/>
-            <a:ext cx="1691640" cy="292608"/>
+            <a:off x="996695" y="2551175"/>
+            <a:ext cx="1664208" cy="256032"/>
           </a:xfrm>
           <a:prstGeom prst="rect">
             <a:avLst/>
@@ -6992,7 +6992,7 @@
           <a:p>
             <a:pPr algn="ctr"/>
             <a:r>
-              <a:rPr sz="1050" b="1" i="0">
+              <a:rPr sz="1000" b="1" i="0">
                 <a:solidFill>
                   <a:srgbClr val="00E676"/>
                 </a:solidFill>
@@ -7010,8 +7010,8 @@
         </p:nvSpPr>
         <p:spPr>
           <a:xfrm>
-            <a:off x="982980" y="4471416"/>
-            <a:ext cx="1691640" cy="274320"/>
+            <a:off x="996695" y="2798063"/>
+            <a:ext cx="1664208" cy="237744"/>
           </a:xfrm>
           <a:prstGeom prst="rect">
             <a:avLst/>
@@ -7026,7 +7026,7 @@
           <a:p>
             <a:pPr algn="ctr"/>
             <a:r>
-              <a:rPr sz="900" b="0" i="0">
+              <a:rPr sz="850" b="0" i="0">
                 <a:solidFill>
                   <a:srgbClr val="CCCCCC"/>
                 </a:solidFill>
@@ -7044,8 +7044,8 @@
         </p:nvSpPr>
         <p:spPr>
           <a:xfrm>
-            <a:off x="3817620" y="4151376"/>
-            <a:ext cx="1691640" cy="658368"/>
+            <a:off x="3831335" y="2505456"/>
+            <a:ext cx="1664208" cy="566928"/>
           </a:xfrm>
           <a:prstGeom prst="rect">
             <a:avLst/>
@@ -7089,8 +7089,8 @@
         </p:nvSpPr>
         <p:spPr>
           <a:xfrm>
-            <a:off x="3817620" y="4151376"/>
-            <a:ext cx="1691640" cy="45720"/>
+            <a:off x="3831335" y="2505456"/>
+            <a:ext cx="1664208" cy="45720"/>
           </a:xfrm>
           <a:prstGeom prst="rect">
             <a:avLst/>
@@ -7132,8 +7132,8 @@
         </p:nvSpPr>
         <p:spPr>
           <a:xfrm>
-            <a:off x="3817620" y="4187952"/>
-            <a:ext cx="1691640" cy="292608"/>
+            <a:off x="3831335" y="2551175"/>
+            <a:ext cx="1664208" cy="256032"/>
           </a:xfrm>
           <a:prstGeom prst="rect">
             <a:avLst/>
@@ -7148,7 +7148,7 @@
           <a:p>
             <a:pPr algn="ctr"/>
             <a:r>
-              <a:rPr sz="1050" b="1" i="0">
+              <a:rPr sz="1000" b="1" i="0">
                 <a:solidFill>
                   <a:srgbClr val="00C85A"/>
                 </a:solidFill>
@@ -7166,8 +7166,8 @@
         </p:nvSpPr>
         <p:spPr>
           <a:xfrm>
-            <a:off x="3817620" y="4471416"/>
-            <a:ext cx="1691640" cy="274320"/>
+            <a:off x="3831335" y="2798063"/>
+            <a:ext cx="1664208" cy="237744"/>
           </a:xfrm>
           <a:prstGeom prst="rect">
             <a:avLst/>
@@ -7182,7 +7182,7 @@
           <a:p>
             <a:pPr algn="ctr"/>
             <a:r>
-              <a:rPr sz="900" b="0" i="0">
+              <a:rPr sz="850" b="0" i="0">
                 <a:solidFill>
                   <a:srgbClr val="CCCCCC"/>
                 </a:solidFill>
@@ -7200,8 +7200,8 @@
         </p:nvSpPr>
         <p:spPr>
           <a:xfrm>
-            <a:off x="6652259" y="4151376"/>
-            <a:ext cx="1691640" cy="658368"/>
+            <a:off x="6665975" y="2505456"/>
+            <a:ext cx="1664208" cy="566928"/>
           </a:xfrm>
           <a:prstGeom prst="rect">
             <a:avLst/>
@@ -7245,8 +7245,8 @@
         </p:nvSpPr>
         <p:spPr>
           <a:xfrm>
-            <a:off x="6652259" y="4151376"/>
-            <a:ext cx="1691640" cy="45720"/>
+            <a:off x="6665975" y="2505456"/>
+            <a:ext cx="1664208" cy="45720"/>
           </a:xfrm>
           <a:prstGeom prst="rect">
             <a:avLst/>
@@ -7288,8 +7288,8 @@
         </p:nvSpPr>
         <p:spPr>
           <a:xfrm>
-            <a:off x="6652259" y="4187952"/>
-            <a:ext cx="1691640" cy="292608"/>
+            <a:off x="6665975" y="2551175"/>
+            <a:ext cx="1664208" cy="256032"/>
           </a:xfrm>
           <a:prstGeom prst="rect">
             <a:avLst/>
@@ -7304,7 +7304,7 @@
           <a:p>
             <a:pPr algn="ctr"/>
             <a:r>
-              <a:rPr sz="1050" b="1" i="0">
+              <a:rPr sz="1000" b="1" i="0">
                 <a:solidFill>
                   <a:srgbClr val="00AA44"/>
                 </a:solidFill>
@@ -7322,8 +7322,8 @@
         </p:nvSpPr>
         <p:spPr>
           <a:xfrm>
-            <a:off x="6652259" y="4471416"/>
-            <a:ext cx="1691640" cy="274320"/>
+            <a:off x="6665975" y="2798063"/>
+            <a:ext cx="1664208" cy="237744"/>
           </a:xfrm>
           <a:prstGeom prst="rect">
             <a:avLst/>
@@ -7338,7 +7338,7 @@
           <a:p>
             <a:pPr algn="ctr"/>
             <a:r>
-              <a:rPr sz="900" b="0" i="0">
+              <a:rPr sz="850" b="0" i="0">
                 <a:solidFill>
                   <a:srgbClr val="CCCCCC"/>
                 </a:solidFill>
@@ -7356,8 +7356,8 @@
         </p:nvSpPr>
         <p:spPr>
           <a:xfrm>
-            <a:off x="3817620" y="5340096"/>
-            <a:ext cx="1691640" cy="658368"/>
+            <a:off x="3831335" y="3465575"/>
+            <a:ext cx="1664208" cy="566928"/>
           </a:xfrm>
           <a:prstGeom prst="rect">
             <a:avLst/>
@@ -7401,8 +7401,8 @@
         </p:nvSpPr>
         <p:spPr>
           <a:xfrm>
-            <a:off x="3817620" y="5340096"/>
-            <a:ext cx="1691640" cy="45720"/>
+            <a:off x="3831335" y="3465575"/>
+            <a:ext cx="1664208" cy="45720"/>
           </a:xfrm>
           <a:prstGeom prst="rect">
             <a:avLst/>
@@ -7444,8 +7444,8 @@
         </p:nvSpPr>
         <p:spPr>
           <a:xfrm>
-            <a:off x="3817620" y="5376672"/>
-            <a:ext cx="1691640" cy="292608"/>
+            <a:off x="3831335" y="3511295"/>
+            <a:ext cx="1664208" cy="256032"/>
           </a:xfrm>
           <a:prstGeom prst="rect">
             <a:avLst/>
@@ -7460,7 +7460,7 @@
           <a:p>
             <a:pPr algn="ctr"/>
             <a:r>
-              <a:rPr sz="1050" b="1" i="0">
+              <a:rPr sz="1000" b="1" i="0">
                 <a:solidFill>
                   <a:srgbClr val="FF6D00"/>
                 </a:solidFill>
@@ -7478,8 +7478,8 @@
         </p:nvSpPr>
         <p:spPr>
           <a:xfrm>
-            <a:off x="3817620" y="5660136"/>
-            <a:ext cx="1691640" cy="274320"/>
+            <a:off x="3831335" y="3758183"/>
+            <a:ext cx="1664208" cy="237744"/>
           </a:xfrm>
           <a:prstGeom prst="rect">
             <a:avLst/>
@@ -7494,7 +7494,7 @@
           <a:p>
             <a:pPr algn="ctr"/>
             <a:r>
-              <a:rPr sz="900" b="0" i="0">
+              <a:rPr sz="850" b="0" i="0">
                 <a:solidFill>
                   <a:srgbClr val="CCCCCC"/>
                 </a:solidFill>
@@ -7512,8 +7512,8 @@
         </p:nvSpPr>
         <p:spPr>
           <a:xfrm>
-            <a:off x="3817620" y="6437376"/>
-            <a:ext cx="1691640" cy="658368"/>
+            <a:off x="3831335" y="4425696"/>
+            <a:ext cx="1664208" cy="566928"/>
           </a:xfrm>
           <a:prstGeom prst="rect">
             <a:avLst/>
@@ -7557,8 +7557,8 @@
         </p:nvSpPr>
         <p:spPr>
           <a:xfrm>
-            <a:off x="3817620" y="6437376"/>
-            <a:ext cx="1691640" cy="45720"/>
+            <a:off x="3831335" y="4425696"/>
+            <a:ext cx="1664208" cy="45720"/>
           </a:xfrm>
           <a:prstGeom prst="rect">
             <a:avLst/>
@@ -7600,8 +7600,8 @@
         </p:nvSpPr>
         <p:spPr>
           <a:xfrm>
-            <a:off x="3817620" y="6473952"/>
-            <a:ext cx="1691640" cy="292608"/>
+            <a:off x="3831335" y="4471416"/>
+            <a:ext cx="1664208" cy="256032"/>
           </a:xfrm>
           <a:prstGeom prst="rect">
             <a:avLst/>
@@ -7616,7 +7616,7 @@
           <a:p>
             <a:pPr algn="ctr"/>
             <a:r>
-              <a:rPr sz="1050" b="1" i="0">
+              <a:rPr sz="1000" b="1" i="0">
                 <a:solidFill>
                   <a:srgbClr val="E63946"/>
                 </a:solidFill>
@@ -7634,8 +7634,8 @@
         </p:nvSpPr>
         <p:spPr>
           <a:xfrm>
-            <a:off x="3817620" y="6757416"/>
-            <a:ext cx="1691640" cy="274320"/>
+            <a:off x="3831335" y="4718304"/>
+            <a:ext cx="1664208" cy="237744"/>
           </a:xfrm>
           <a:prstGeom prst="rect">
             <a:avLst/>
@@ -7650,7 +7650,7 @@
           <a:p>
             <a:pPr algn="ctr"/>
             <a:r>
-              <a:rPr sz="900" b="0" i="0">
+              <a:rPr sz="850" b="0" i="0">
                 <a:solidFill>
                   <a:srgbClr val="CCCCCC"/>
                 </a:solidFill>
@@ -7668,8 +7668,8 @@
         </p:nvSpPr>
         <p:spPr>
           <a:xfrm>
-            <a:off x="274320" y="7726679"/>
-            <a:ext cx="11640312" cy="658368"/>
+            <a:off x="274320" y="5577840"/>
+            <a:ext cx="11640312" cy="566928"/>
           </a:xfrm>
           <a:prstGeom prst="rect">
             <a:avLst/>
@@ -7713,7 +7713,7 @@
         </p:nvSpPr>
         <p:spPr>
           <a:xfrm>
-            <a:off x="274320" y="7726679"/>
+            <a:off x="274320" y="5577840"/>
             <a:ext cx="11640312" cy="45720"/>
           </a:xfrm>
           <a:prstGeom prst="rect">
@@ -7756,8 +7756,8 @@
         </p:nvSpPr>
         <p:spPr>
           <a:xfrm>
-            <a:off x="274320" y="7763256"/>
-            <a:ext cx="5486400" cy="292608"/>
+            <a:off x="457200" y="5623559"/>
+            <a:ext cx="3200400" cy="256032"/>
           </a:xfrm>
           <a:prstGeom prst="rect">
             <a:avLst/>
@@ -7770,9 +7770,9 @@
           </a:bodyPr>
           <a:lstStyle/>
           <a:p>
-            <a:pPr algn="ctr"/>
-            <a:r>
-              <a:rPr sz="1100" b="1" i="0">
+            <a:pPr algn="l"/>
+            <a:r>
+              <a:rPr sz="1050" b="1" i="0">
                 <a:solidFill>
                   <a:srgbClr val="9B5DE5"/>
                 </a:solidFill>
@@ -7790,8 +7790,8 @@
         </p:nvSpPr>
         <p:spPr>
           <a:xfrm>
-            <a:off x="274320" y="8065008"/>
-            <a:ext cx="11640312" cy="274320"/>
+            <a:off x="3657600" y="5623559"/>
+            <a:ext cx="8229600" cy="256032"/>
           </a:xfrm>
           <a:prstGeom prst="rect">
             <a:avLst/>
@@ -7804,14 +7804,14 @@
           </a:bodyPr>
           <a:lstStyle/>
           <a:p>
-            <a:pPr algn="ctr"/>
+            <a:pPr algn="l"/>
             <a:r>
               <a:rPr sz="900" b="0" i="0">
                 <a:solidFill>
                   <a:srgbClr val="CCCCCC"/>
                 </a:solidFill>
               </a:rPr>
-              <a:t>Live Signal  ·  Model Metrics  ·  Feature Importance  ·  Radar Chart  ·  Cumulative Returns  ·  Investment Calculator</a:t>
+              <a:t>Live Signal  ·  Metrics  ·  Feature Importance  ·  Radar Chart  ·  Returns Graph  ·  Investment Calculator</a:t>
             </a:r>
           </a:p>
         </p:txBody>
@@ -7824,8 +7824,8 @@
         </p:nvCxnSpPr>
         <p:spPr>
           <a:xfrm>
-            <a:off x="1851660" y="1417320"/>
-            <a:ext cx="137159" cy="0"/>
+            <a:off x="1837944" y="960120"/>
+            <a:ext cx="164592" cy="0"/>
           </a:xfrm>
           <a:prstGeom prst="line">
             <a:avLst/>
@@ -7859,8 +7859,8 @@
         </p:nvCxnSpPr>
         <p:spPr>
           <a:xfrm>
-            <a:off x="3680460" y="1417320"/>
-            <a:ext cx="137160" cy="0"/>
+            <a:off x="3666744" y="960120"/>
+            <a:ext cx="164591" cy="0"/>
           </a:xfrm>
           <a:prstGeom prst="line">
             <a:avLst/>
@@ -7894,8 +7894,8 @@
         </p:nvCxnSpPr>
         <p:spPr>
           <a:xfrm>
-            <a:off x="5509259" y="1417320"/>
-            <a:ext cx="137161" cy="0"/>
+            <a:off x="5495544" y="960120"/>
+            <a:ext cx="164592" cy="0"/>
           </a:xfrm>
           <a:prstGeom prst="line">
             <a:avLst/>
@@ -7929,8 +7929,8 @@
         </p:nvCxnSpPr>
         <p:spPr>
           <a:xfrm>
-            <a:off x="7338060" y="1417320"/>
-            <a:ext cx="320040" cy="0"/>
+            <a:off x="7324344" y="960120"/>
+            <a:ext cx="347472" cy="0"/>
           </a:xfrm>
           <a:prstGeom prst="line">
             <a:avLst/>
@@ -7964,8 +7964,8 @@
         </p:nvCxnSpPr>
         <p:spPr>
           <a:xfrm flipH="1">
-            <a:off x="4663440" y="1746504"/>
-            <a:ext cx="3840480" cy="941832"/>
+            <a:off x="4663440" y="1243584"/>
+            <a:ext cx="3840480" cy="347471"/>
           </a:xfrm>
           <a:prstGeom prst="line">
             <a:avLst/>
@@ -7999,8 +7999,8 @@
         </p:nvCxnSpPr>
         <p:spPr>
           <a:xfrm flipH="1">
-            <a:off x="1828800" y="3346703"/>
-            <a:ext cx="2834640" cy="804673"/>
+            <a:off x="1828800" y="2157984"/>
+            <a:ext cx="2834640" cy="347472"/>
           </a:xfrm>
           <a:prstGeom prst="line">
             <a:avLst/>
@@ -8034,8 +8034,8 @@
         </p:nvCxnSpPr>
         <p:spPr>
           <a:xfrm>
-            <a:off x="4663440" y="3346703"/>
-            <a:ext cx="0" cy="804673"/>
+            <a:off x="4663440" y="2157984"/>
+            <a:ext cx="0" cy="347472"/>
           </a:xfrm>
           <a:prstGeom prst="line">
             <a:avLst/>
@@ -8069,8 +8069,8 @@
         </p:nvCxnSpPr>
         <p:spPr>
           <a:xfrm>
-            <a:off x="4663440" y="3346703"/>
-            <a:ext cx="2834639" cy="804673"/>
+            <a:off x="4663440" y="2157984"/>
+            <a:ext cx="2834639" cy="347472"/>
           </a:xfrm>
           <a:prstGeom prst="line">
             <a:avLst/>
@@ -8104,8 +8104,8 @@
         </p:nvCxnSpPr>
         <p:spPr>
           <a:xfrm>
-            <a:off x="1828800" y="4809744"/>
-            <a:ext cx="2834640" cy="530352"/>
+            <a:off x="1828800" y="3072384"/>
+            <a:ext cx="2834640" cy="393191"/>
           </a:xfrm>
           <a:prstGeom prst="line">
             <a:avLst/>
@@ -8139,8 +8139,8 @@
         </p:nvCxnSpPr>
         <p:spPr>
           <a:xfrm>
-            <a:off x="4663440" y="4809744"/>
-            <a:ext cx="0" cy="530352"/>
+            <a:off x="4663440" y="3072384"/>
+            <a:ext cx="0" cy="393191"/>
           </a:xfrm>
           <a:prstGeom prst="line">
             <a:avLst/>
@@ -8174,8 +8174,8 @@
         </p:nvCxnSpPr>
         <p:spPr>
           <a:xfrm flipH="1">
-            <a:off x="4663440" y="4809744"/>
-            <a:ext cx="2834639" cy="530352"/>
+            <a:off x="4663440" y="3072384"/>
+            <a:ext cx="2834639" cy="393191"/>
           </a:xfrm>
           <a:prstGeom prst="line">
             <a:avLst/>
@@ -8209,8 +8209,8 @@
         </p:nvCxnSpPr>
         <p:spPr>
           <a:xfrm>
-            <a:off x="4663440" y="5998464"/>
-            <a:ext cx="0" cy="438912"/>
+            <a:off x="4663440" y="4032503"/>
+            <a:ext cx="0" cy="393193"/>
           </a:xfrm>
           <a:prstGeom prst="line">
             <a:avLst/>
@@ -8244,8 +8244,8 @@
         </p:nvCxnSpPr>
         <p:spPr>
           <a:xfrm>
-            <a:off x="4663440" y="7095744"/>
-            <a:ext cx="0" cy="630935"/>
+            <a:off x="4663440" y="4992624"/>
+            <a:ext cx="0" cy="585216"/>
           </a:xfrm>
           <a:prstGeom prst="line">
             <a:avLst/>

</xml_diff>